<commit_message>
feat(prezentatsiya): yangi fayl nomi va versiya banneri
Eski Yorqin/Vaaav cache chalkashligini oldini olish uchun
Python-Dars-01-YANGI.pptx va birinchi slaydda qizil YANGI VERSIYA banneri.

Co-authored-by: Dilshod Zokirov <DilshodZokirov@users.noreply.github.com>
</commit_message>
<xml_diff>
--- a/python-prezentatsiya/Python-Django-Yorqin.pptx
+++ b/python-prezentatsiya/Python-Django-Yorqin.pptx
@@ -3154,7 +3154,91 @@
       </p:sp>
       <p:sp>
         <p:nvSpPr>
-          <p:cNvPr id="3" name="Rounded Rectangle 2"/>
+          <p:cNvPr id="3" name="Rectangle 2"/>
+          <p:cNvSpPr/>
+          <p:nvPr/>
+        </p:nvSpPr>
+        <p:spPr>
+          <a:xfrm>
+            <a:off x="502920" y="320040"/>
+            <a:ext cx="11155680" cy="502920"/>
+          </a:xfrm>
+          <a:prstGeom prst="rect">
+            <a:avLst/>
+          </a:prstGeom>
+          <a:solidFill>
+            <a:srgbClr val="BE123C"/>
+          </a:solidFill>
+          <a:ln>
+            <a:noFill/>
+          </a:ln>
+        </p:spPr>
+        <p:style>
+          <a:lnRef idx="1">
+            <a:schemeClr val="accent1"/>
+          </a:lnRef>
+          <a:fillRef idx="3">
+            <a:schemeClr val="accent1"/>
+          </a:fillRef>
+          <a:effectRef idx="2">
+            <a:schemeClr val="accent1"/>
+          </a:effectRef>
+          <a:fontRef idx="minor">
+            <a:schemeClr val="lt1"/>
+          </a:fontRef>
+        </p:style>
+        <p:txBody>
+          <a:bodyPr rtlCol="0" anchor="ctr"/>
+          <a:lstStyle/>
+          <a:p>
+            <a:pPr algn="ctr"/>
+          </a:p>
+        </p:txBody>
+      </p:sp>
+      <p:sp>
+        <p:nvSpPr>
+          <p:cNvPr id="4" name="TextBox 3"/>
+          <p:cNvSpPr txBox="1"/>
+          <p:nvPr/>
+        </p:nvSpPr>
+        <p:spPr>
+          <a:xfrm>
+            <a:off x="502920" y="365760"/>
+            <a:ext cx="11155680" cy="411480"/>
+          </a:xfrm>
+          <a:prstGeom prst="rect">
+            <a:avLst/>
+          </a:prstGeom>
+          <a:noFill/>
+        </p:spPr>
+        <p:txBody>
+          <a:bodyPr wrap="square" anchor="ctr">
+            <a:spAutoFit/>
+          </a:bodyPr>
+          <a:lstStyle/>
+          <a:p>
+            <a:pPr algn="ctr">
+              <a:spcAft>
+                <a:spcPts val="0"/>
+              </a:spcAft>
+            </a:pPr>
+            <a:r>
+              <a:rPr sz="1400" b="1">
+                <a:cs typeface="Calibri"/>
+                <a:ea typeface="Calibri"/>
+                <a:solidFill>
+                  <a:srgbClr val="FFFFFF"/>
+                </a:solidFill>
+                <a:latin typeface="Calibri"/>
+              </a:rPr>
+              <a:t>YANGI VERSIYA · 2026-08-04 · 2-slaydda Java vs Python kod bo‘lsa — to‘g‘ri fayl</a:t>
+            </a:r>
+          </a:p>
+        </p:txBody>
+      </p:sp>
+      <p:sp>
+        <p:nvSpPr>
+          <p:cNvPr id="5" name="Rounded Rectangle 4"/>
           <p:cNvSpPr/>
           <p:nvPr/>
         </p:nvSpPr>
@@ -3197,7 +3281,7 @@
       </p:sp>
       <p:sp>
         <p:nvSpPr>
-          <p:cNvPr id="4" name="TextBox 3"/>
+          <p:cNvPr id="6" name="TextBox 5"/>
           <p:cNvSpPr txBox="1"/>
           <p:nvPr/>
         </p:nvSpPr>
@@ -3238,7 +3322,7 @@
       </p:sp>
       <p:sp>
         <p:nvSpPr>
-          <p:cNvPr id="5" name="TextBox 4"/>
+          <p:cNvPr id="7" name="TextBox 6"/>
           <p:cNvSpPr txBox="1"/>
           <p:nvPr/>
         </p:nvSpPr>

</xml_diff>